<commit_message>
resultats minsup ESBL 2019-2021 2
</commit_message>
<xml_diff>
--- a/results_minsup_ESBL/minsup_0_001/rep6/plots_reseaux/graph_2022_BLSE_0.95.pptx
+++ b/results_minsup_ESBL/minsup_0_001/rep6/plots_reseaux/graph_2022_BLSE_0.95.pptx
@@ -7895,7 +7895,7 @@
             </a:custGeom>
             <a:ln w="9525" cap="rnd">
               <a:solidFill>
-                <a:srgbClr val="6A0000">
+                <a:srgbClr val="A72829">
                   <a:alpha val="100000"/>
                 </a:srgbClr>
               </a:solidFill>
@@ -8335,7 +8335,7 @@
             </a:custGeom>
             <a:ln w="9525" cap="rnd">
               <a:solidFill>
-                <a:srgbClr val="6A0000">
+                <a:srgbClr val="A72829">
                   <a:alpha val="100000"/>
                 </a:srgbClr>
               </a:solidFill>

</xml_diff>